<commit_message>
Report and poster: add group members, guide and HOD; three-member contributions
Fill in Shivam Mulani, Gurshaan Nandrajog and Harshvarddhan Waghela with
UIDs, guide Prof. Anant Nimkar and HOD Dr. Sudhir Dhage; remove the fourth
member slot; divide contributions by module; demo roles for three people.

Co-Authored-By: Claude Opus 5.5 <noreply@anthropic.com>
Claude-Session: https://claude.ai/code/session_01KryhxVroGKYr2NL7r5C2Fb
</commit_message>
<xml_diff>
--- a/report/86_Dynamic_Timetable_Monitoring_System/poster/86_Dynamic_Timetable_Poster.pptx
+++ b/report/86_Dynamic_Timetable_Monitoring_System/poster/86_Dynamic_Timetable_Poster.pptx
@@ -1376,7 +1376,7 @@
                 <a:latin typeface="Bookman Old Style"/>
                 <a:ea typeface="Times New Roman"/>
               </a:rPr>
-              <a:t>Shivam Mulani, Member 2 Name, Member 3 Name, Member 4 Name, B.Tech.(Comp.)</a:t>
+              <a:t>Shivam Mulani, Gurshaan Nandrajog, Harshvarddhan Waghela, B.Tech.(Comp.)</a:t>
             </a:r>
             <a:endParaRPr b="0" lang="en-US" sz="2400" spc="-1" strike="noStrike">
               <a:solidFill>
@@ -1433,7 +1433,7 @@
                 <a:latin typeface="Bookman Old Style"/>
                 <a:ea typeface="Times New Roman"/>
               </a:rPr>
-              <a:t>Project Guide: Prof. Guide Name  |  Group No. 86</a:t>
+              <a:t>Project Guide: Prof. Anant Nimkar  |  Group No. 86</a:t>
             </a:r>
             <a:endParaRPr b="0" lang="en-US" sz="2400" spc="-1" strike="noStrike">
               <a:solidFill>

</xml_diff>